<commit_message>
Runner issues log: Windows full runs
Co-authored-by: Copilot <223556219+Copilot@users.noreply.github.com>
</commit_message>
<xml_diff>
--- a/slides/01-weather-view.pptx
+++ b/slides/01-weather-view.pptx
@@ -5574,7 +5574,7 @@
         <p:spPr>
           <a:xfrm>
             <a:off x="1290340" y="2467273"/>
-            <a:ext cx="498830" cy="133350"/>
+            <a:ext cx="1220054" cy="133350"/>
           </a:xfrm>
           <a:prstGeom prst="rect">
             <a:avLst/>
@@ -5590,15 +5590,29 @@
               <a:buNone/>
             </a:pPr>
             <a:r>
+              <a:rPr lang="en-US" sz="900" dirty="0">
+                <a:solidFill>
+                  <a:srgbClr val="8250DF"/>
+                </a:solidFill>
+                <a:latin typeface="Arial" pitchFamily="34" charset="0"/>
+                <a:ea typeface="Arial" pitchFamily="34" charset="-122"/>
+                <a:cs typeface="Arial" pitchFamily="34" charset="-120"/>
+              </a:rPr>
+              <a:t>PROMPT</a:t>
+            </a:r>
+            <a:pPr algn="l" indent="0" marL="0">
+              <a:buNone/>
+            </a:pPr>
+            <a:r>
               <a:rPr lang="en-US" sz="900" b="1" dirty="0">
                 <a:solidFill>
-                  <a:srgbClr val="8250DF"/>
-                </a:solidFill>
-                <a:latin typeface="Arial" pitchFamily="34" charset="0"/>
-                <a:ea typeface="Arial" pitchFamily="34" charset="-122"/>
-                <a:cs typeface="Arial" pitchFamily="34" charset="-120"/>
-              </a:rPr>
-              <a:t>PROMPT</a:t>
+                  <a:srgbClr val="818B98"/>
+                </a:solidFill>
+                <a:latin typeface="Arial" pitchFamily="34" charset="0"/>
+                <a:ea typeface="Arial" pitchFamily="34" charset="-122"/>
+                <a:cs typeface="Arial" pitchFamily="34" charset="-120"/>
+              </a:rPr>
+              <a:t> · ABRIDGED</a:t>
             </a:r>
             <a:endParaRPr lang="en-US" sz="900" dirty="0"/>
           </a:p>
@@ -5674,7 +5688,7 @@
                 <a:ea typeface="Arial" pitchFamily="34" charset="-122"/>
                 <a:cs typeface="Arial" pitchFamily="34" charset="-120"/>
               </a:rPr>
-              <a:t> that I'll undo.</a:t>
+              <a:t> that I'll undo. …</a:t>
             </a:r>
             <a:endParaRPr lang="en-US" sz="1500" dirty="0"/>
           </a:p>

</xml_diff>